<commit_message>
Slide 8 donut: add shape-overlay percentage labels at arc midpoints
Previous pass removed native labels (they sit inside the ring at a
fixed size and can't be typographically controlled). Replaced with
shape overlays: one percentage per slice, positioned at the arc
midpoint of each slice via sin/cos math. Text color per slice so
the label reads on STEEL / LBLUE / BERRY fills (white / ink / white).

Chart's job is proportion (% on the ring); right column keeps its
job of tabular readout ($M, descriptor, order). No redundancy.

Co-Authored-By: Claude Opus 4.7 (1M context) <noreply@anthropic.com>
</commit_message>
<xml_diff>
--- a/output/audit_deck.pptx
+++ b/output/audit_deck.pptx
@@ -13364,6 +13364,123 @@
         </p:nvSpPr>
         <p:spPr>
           <a:xfrm>
+            <a:off x="4172881" y="3142548"/>
+            <a:ext cx="914400" cy="365760"/>
+          </a:xfrm>
+          <a:prstGeom prst="rect">
+            <a:avLst/>
+          </a:prstGeom>
+          <a:noFill/>
+          <a:ln/>
+        </p:spPr>
+        <p:txBody>
+          <a:bodyPr wrap="square" lIns="0" tIns="0" rIns="0" bIns="0" rtlCol="0" anchor="ctr"/>
+          <a:lstStyle/>
+          <a:p>
+            <a:pPr algn="ctr" indent="0" marL="0">
+              <a:buNone/>
+            </a:pPr>
+            <a:r>
+              <a:rPr lang="en-US" sz="1800" dirty="0">
+                <a:solidFill>
+                  <a:srgbClr val="FFFFFF"/>
+                </a:solidFill>
+                <a:latin typeface="Georgia" pitchFamily="34" charset="0"/>
+                <a:ea typeface="Georgia" pitchFamily="34" charset="-122"/>
+                <a:cs typeface="Georgia" pitchFamily="34" charset="-120"/>
+              </a:rPr>
+              <a:t>31%</a:t>
+            </a:r>
+            <a:endParaRPr lang="en-US" sz="1800" dirty="0"/>
+          </a:p>
+        </p:txBody>
+      </p:sp>
+      <p:sp>
+        <p:nvSpPr>
+          <p:cNvPr id="7" name="Text 4"/>
+          <p:cNvSpPr/>
+          <p:nvPr/>
+        </p:nvSpPr>
+        <p:spPr>
+          <a:xfrm>
+            <a:off x="3275471" y="5068996"/>
+            <a:ext cx="914400" cy="365760"/>
+          </a:xfrm>
+          <a:prstGeom prst="rect">
+            <a:avLst/>
+          </a:prstGeom>
+          <a:noFill/>
+          <a:ln/>
+        </p:spPr>
+        <p:txBody>
+          <a:bodyPr wrap="square" lIns="0" tIns="0" rIns="0" bIns="0" rtlCol="0" anchor="ctr"/>
+          <a:lstStyle/>
+          <a:p>
+            <a:pPr algn="ctr" indent="0" marL="0">
+              <a:buNone/>
+            </a:pPr>
+            <a:r>
+              <a:rPr lang="en-US" sz="1800" dirty="0">
+                <a:solidFill>
+                  <a:srgbClr val="353745"/>
+                </a:solidFill>
+                <a:latin typeface="Georgia" pitchFamily="34" charset="0"/>
+                <a:ea typeface="Georgia" pitchFamily="34" charset="-122"/>
+                <a:cs typeface="Georgia" pitchFamily="34" charset="-120"/>
+              </a:rPr>
+              <a:t>35%</a:t>
+            </a:r>
+            <a:endParaRPr lang="en-US" sz="1800" dirty="0"/>
+          </a:p>
+        </p:txBody>
+      </p:sp>
+      <p:sp>
+        <p:nvSpPr>
+          <p:cNvPr id="8" name="Text 5"/>
+          <p:cNvSpPr/>
+          <p:nvPr/>
+        </p:nvSpPr>
+        <p:spPr>
+          <a:xfrm>
+            <a:off x="2073072" y="3245529"/>
+            <a:ext cx="914400" cy="365760"/>
+          </a:xfrm>
+          <a:prstGeom prst="rect">
+            <a:avLst/>
+          </a:prstGeom>
+          <a:noFill/>
+          <a:ln/>
+        </p:spPr>
+        <p:txBody>
+          <a:bodyPr wrap="square" lIns="0" tIns="0" rIns="0" bIns="0" rtlCol="0" anchor="ctr"/>
+          <a:lstStyle/>
+          <a:p>
+            <a:pPr algn="ctr" indent="0" marL="0">
+              <a:buNone/>
+            </a:pPr>
+            <a:r>
+              <a:rPr lang="en-US" sz="1800" dirty="0">
+                <a:solidFill>
+                  <a:srgbClr val="FFFFFF"/>
+                </a:solidFill>
+                <a:latin typeface="Georgia" pitchFamily="34" charset="0"/>
+                <a:ea typeface="Georgia" pitchFamily="34" charset="-122"/>
+                <a:cs typeface="Georgia" pitchFamily="34" charset="-120"/>
+              </a:rPr>
+              <a:t>34%</a:t>
+            </a:r>
+            <a:endParaRPr lang="en-US" sz="1800" dirty="0"/>
+          </a:p>
+        </p:txBody>
+      </p:sp>
+      <p:sp>
+        <p:nvSpPr>
+          <p:cNvPr id="9" name="Text 6"/>
+          <p:cNvSpPr/>
+          <p:nvPr/>
+        </p:nvSpPr>
+        <p:spPr>
+          <a:xfrm>
             <a:off x="6766560" y="2103120"/>
             <a:ext cx="4846320" cy="256032"/>
           </a:xfrm>
@@ -13397,7 +13514,7 @@
       </p:sp>
       <p:sp>
         <p:nvSpPr>
-          <p:cNvPr id="7" name="Shape 4"/>
+          <p:cNvPr id="10" name="Shape 7"/>
           <p:cNvSpPr/>
           <p:nvPr/>
         </p:nvSpPr>
@@ -13420,7 +13537,7 @@
       </p:sp>
       <p:sp>
         <p:nvSpPr>
-          <p:cNvPr id="8" name="Text 5"/>
+          <p:cNvPr id="11" name="Text 8"/>
           <p:cNvSpPr/>
           <p:nvPr/>
         </p:nvSpPr>
@@ -13459,7 +13576,7 @@
       </p:sp>
       <p:sp>
         <p:nvSpPr>
-          <p:cNvPr id="9" name="Shape 6"/>
+          <p:cNvPr id="12" name="Shape 9"/>
           <p:cNvSpPr/>
           <p:nvPr/>
         </p:nvSpPr>
@@ -13479,7 +13596,7 @@
       </p:sp>
       <p:sp>
         <p:nvSpPr>
-          <p:cNvPr id="10" name="Text 7"/>
+          <p:cNvPr id="13" name="Text 10"/>
           <p:cNvSpPr/>
           <p:nvPr/>
         </p:nvSpPr>
@@ -13518,7 +13635,7 @@
       </p:sp>
       <p:sp>
         <p:nvSpPr>
-          <p:cNvPr id="11" name="Text 8"/>
+          <p:cNvPr id="14" name="Text 11"/>
           <p:cNvSpPr/>
           <p:nvPr/>
         </p:nvSpPr>
@@ -13557,7 +13674,7 @@
       </p:sp>
       <p:sp>
         <p:nvSpPr>
-          <p:cNvPr id="12" name="Text 9"/>
+          <p:cNvPr id="15" name="Text 12"/>
           <p:cNvSpPr/>
           <p:nvPr/>
         </p:nvSpPr>
@@ -13596,7 +13713,7 @@
       </p:sp>
       <p:sp>
         <p:nvSpPr>
-          <p:cNvPr id="13" name="Shape 10"/>
+          <p:cNvPr id="16" name="Shape 13"/>
           <p:cNvSpPr/>
           <p:nvPr/>
         </p:nvSpPr>
@@ -13616,7 +13733,7 @@
       </p:sp>
       <p:sp>
         <p:nvSpPr>
-          <p:cNvPr id="14" name="Text 11"/>
+          <p:cNvPr id="17" name="Text 14"/>
           <p:cNvSpPr/>
           <p:nvPr/>
         </p:nvSpPr>
@@ -13655,7 +13772,7 @@
       </p:sp>
       <p:sp>
         <p:nvSpPr>
-          <p:cNvPr id="15" name="Text 12"/>
+          <p:cNvPr id="18" name="Text 15"/>
           <p:cNvSpPr/>
           <p:nvPr/>
         </p:nvSpPr>
@@ -13694,7 +13811,7 @@
       </p:sp>
       <p:sp>
         <p:nvSpPr>
-          <p:cNvPr id="16" name="Text 13"/>
+          <p:cNvPr id="19" name="Text 16"/>
           <p:cNvSpPr/>
           <p:nvPr/>
         </p:nvSpPr>
@@ -13733,7 +13850,7 @@
       </p:sp>
       <p:sp>
         <p:nvSpPr>
-          <p:cNvPr id="17" name="Shape 14"/>
+          <p:cNvPr id="20" name="Shape 17"/>
           <p:cNvSpPr/>
           <p:nvPr/>
         </p:nvSpPr>
@@ -13753,7 +13870,7 @@
       </p:sp>
       <p:sp>
         <p:nvSpPr>
-          <p:cNvPr id="18" name="Text 15"/>
+          <p:cNvPr id="21" name="Text 18"/>
           <p:cNvSpPr/>
           <p:nvPr/>
         </p:nvSpPr>
@@ -13792,7 +13909,7 @@
       </p:sp>
       <p:sp>
         <p:nvSpPr>
-          <p:cNvPr id="19" name="Text 16"/>
+          <p:cNvPr id="22" name="Text 19"/>
           <p:cNvSpPr/>
           <p:nvPr/>
         </p:nvSpPr>
@@ -13831,7 +13948,7 @@
       </p:sp>
       <p:sp>
         <p:nvSpPr>
-          <p:cNvPr id="20" name="Text 17"/>
+          <p:cNvPr id="23" name="Text 20"/>
           <p:cNvSpPr/>
           <p:nvPr/>
         </p:nvSpPr>

</xml_diff>

<commit_message>
Slide 8 donut: tune shape-overlay label geometry (final pass)
Reduced label radius 1.35→1.1, font 18pt→14pt bold, box 0.4→0.3, and
added +0.1" downward bias on chart center to compensate for
pptxgenjs's invisible top padding. Empirically tuned for the 6.5×4.4
chart footprint. Formula-free — pptxgenjs pads variably based on
legend/title state.

Donut retained for completeness in the audit deck; per user feedback,
donuts are generally low-preference and bar charts substitute well for
proportional stories.

Co-Authored-By: Claude Opus 4.7 (1M context) <noreply@anthropic.com>
</commit_message>
<xml_diff>
--- a/output/audit_deck.pptx
+++ b/output/audit_deck.pptx
@@ -13364,8 +13364,8 @@
         </p:nvSpPr>
         <p:spPr>
           <a:xfrm>
-            <a:off x="4172881" y="3142548"/>
-            <a:ext cx="914400" cy="365760"/>
+            <a:off x="3984325" y="3408955"/>
+            <a:ext cx="914400" cy="274320"/>
           </a:xfrm>
           <a:prstGeom prst="rect">
             <a:avLst/>
@@ -13381,7 +13381,7 @@
               <a:buNone/>
             </a:pPr>
             <a:r>
-              <a:rPr lang="en-US" sz="1800" dirty="0">
+              <a:rPr lang="en-US" sz="1400" b="1" dirty="0">
                 <a:solidFill>
                   <a:srgbClr val="FFFFFF"/>
                 </a:solidFill>
@@ -13391,7 +13391,7 @@
               </a:rPr>
               <a:t>31%</a:t>
             </a:r>
-            <a:endParaRPr lang="en-US" sz="1800" dirty="0"/>
+            <a:endParaRPr lang="en-US" sz="1400" dirty="0"/>
           </a:p>
         </p:txBody>
       </p:sp>
@@ -13403,8 +13403,8 @@
         </p:nvSpPr>
         <p:spPr>
           <a:xfrm>
-            <a:off x="3275471" y="5068996"/>
-            <a:ext cx="914400" cy="365760"/>
+            <a:off x="3253102" y="4978653"/>
+            <a:ext cx="914400" cy="274320"/>
           </a:xfrm>
           <a:prstGeom prst="rect">
             <a:avLst/>
@@ -13420,7 +13420,7 @@
               <a:buNone/>
             </a:pPr>
             <a:r>
-              <a:rPr lang="en-US" sz="1800" dirty="0">
+              <a:rPr lang="en-US" sz="1400" b="1" dirty="0">
                 <a:solidFill>
                   <a:srgbClr val="353745"/>
                 </a:solidFill>
@@ -13430,7 +13430,7 @@
               </a:rPr>
               <a:t>35%</a:t>
             </a:r>
-            <a:endParaRPr lang="en-US" sz="1800" dirty="0"/>
+            <a:endParaRPr lang="en-US" sz="1400" dirty="0"/>
           </a:p>
         </p:txBody>
       </p:sp>
@@ -13442,8 +13442,8 @@
         </p:nvSpPr>
         <p:spPr>
           <a:xfrm>
-            <a:off x="2073072" y="3245529"/>
-            <a:ext cx="914400" cy="365760"/>
+            <a:off x="2273370" y="3492865"/>
+            <a:ext cx="914400" cy="274320"/>
           </a:xfrm>
           <a:prstGeom prst="rect">
             <a:avLst/>
@@ -13459,7 +13459,7 @@
               <a:buNone/>
             </a:pPr>
             <a:r>
-              <a:rPr lang="en-US" sz="1800" dirty="0">
+              <a:rPr lang="en-US" sz="1400" b="1" dirty="0">
                 <a:solidFill>
                   <a:srgbClr val="FFFFFF"/>
                 </a:solidFill>
@@ -13469,7 +13469,7 @@
               </a:rPr>
               <a:t>34%</a:t>
             </a:r>
-            <a:endParaRPr lang="en-US" sz="1800" dirty="0"/>
+            <a:endParaRPr lang="en-US" sz="1400" dirty="0"/>
           </a:p>
         </p:txBody>
       </p:sp>

</xml_diff>